<commit_message>
Quell-MD-Hygiene: 10 Module neu gesynct (kanonische Headings, AB-X-Arbeitsblaetter nur im PDF)
Co-Authored-By: Claude Opus 4.8 <noreply@anthropic.com>
</commit_message>
<xml_diff>
--- a/protected-downloads/praesentation/M09.pptx
+++ b/protected-downloads/praesentation/M09.pptx
@@ -4666,7 +4666,7 @@
                 </a:solidFill>
                 <a:latin typeface="Source Serif 4"/>
               </a:rPr>
-              <a:t>Arbeitsblatt A: Branchenanalyse – Five Forces Scoring</a:t>
+              <a:t>AB-1: Branchenanalyse – Five Forces Scoring</a:t>
             </a:r>
           </a:p>
         </p:txBody>
@@ -5464,7 +5464,7 @@
                 </a:solidFill>
                 <a:latin typeface="Source Serif 4"/>
               </a:rPr>
-              <a:t>Arbeitsblatt B: Mein 3-Monats-Expertiseplan</a:t>
+              <a:t>AB-2: Mein 3-Monats-Expertiseplan</a:t>
             </a:r>
           </a:p>
         </p:txBody>
@@ -5758,7 +5758,7 @@
                 </a:solidFill>
                 <a:latin typeface="Source Serif 4"/>
               </a:rPr>
-              <a:t>Arbeitsblatt B: Mein 3-Monats-Expertiseplan</a:t>
+              <a:t>AB-2: Mein 3-Monats-Expertiseplan</a:t>
             </a:r>
           </a:p>
         </p:txBody>
@@ -6454,7 +6454,7 @@
                 </a:solidFill>
                 <a:latin typeface="Source Serif 4"/>
               </a:rPr>
-              <a:t>Arbeitsblatt C: Strukturiertes Branchengespräch – Protokollvorlage</a:t>
+              <a:t>AB-3: Strukturiertes Branchengespräch – Protokollvorlage</a:t>
             </a:r>
           </a:p>
         </p:txBody>
@@ -10259,7 +10259,7 @@
                 </a:solidFill>
                 <a:latin typeface="Source Serif 4"/>
               </a:rPr>
-              <a:t>Arbeitsblatt A: Branchenanalyse – Five Forces Scoring</a:t>
+              <a:t>AB-1: Branchenanalyse – Five Forces Scoring</a:t>
             </a:r>
           </a:p>
         </p:txBody>

</xml_diff>